<commit_message>
feat: deepen EDA - tags, friendships, data quality (full multi-source EDA)
Strengthen the previously plays-only EDA to cover all four data sources:
- eda.py helpers (tested): interaction_quality, tag_frequency, tags_per_artist,
  friend_degree, friend_listening_overlap (friends vs random Jaccard)
- scripts/eda_stats.py -> docs/eda_stats.csv (single source for report EDA numbers)
- 01_eda.ipynb rebuilt: data-quality/outliers + tag/genre + friendship sections,
  new figures tag_analysis.png + friendship_analysis.png
- report section 3 expanded (3.1 Tags, 3.2 Friendships), figures renumbered 3-9
- tests: 86 total, 95% coverage; counts updated across report + deck + findings

Key new findings: 29% of artists untagged (content-based ceiling); friends share
4.3x more listening overlap than random pairs (justifies the social recommender);
play-count outlier (max 352,698 vs median 260).
</commit_message>
<xml_diff>
--- a/docs/Music_Recommender_Slide_Deck.pptx
+++ b/docs/Music_Recommender_Slide_Deck.pptx
@@ -15315,7 +15315,7 @@
                 <a:ea typeface="Courier New" pitchFamily="34" charset="-122"/>
                 <a:cs typeface="Courier New" pitchFamily="34" charset="-120"/>
               </a:rPr>
-              <a:t>81</a:t>
+              <a:t>86</a:t>
             </a:r>
             <a:endParaRPr lang="en-US" sz="3750" dirty="0"/>
           </a:p>
@@ -15397,7 +15397,7 @@
                 <a:ea typeface="Courier New" pitchFamily="34" charset="-122"/>
                 <a:cs typeface="Courier New" pitchFamily="34" charset="-120"/>
               </a:rPr>
-              <a:t>94%</a:t>
+              <a:t>95%</a:t>
             </a:r>
             <a:endParaRPr lang="en-US" sz="3750" dirty="0"/>
           </a:p>

</xml_diff>